<commit_message>
add Khmer slides for Week01-12 and WeekGit
- Add generate_slides.py + PPTX for Week01 (MVVM), Week02 (CoreData), WeekGit (Git Fundamentals)
- Rewrite Week05-07 slides as dark-theme Khmer decks (Calendar, Pest Guide, Daily Journal)
- Translate Week08-10, Week12 slide scripts fully into Khmer (titles, bullets, descriptions)
- Rewrite Week01 and Week02 READMEs with iOS 13+ patterns and cleaner structure

Co-Authored-By: Claude Sonnet 4.6 <noreply@anthropic.com>
</commit_message>
<xml_diff>
--- a/Week08/Week08_Dashboard_Tab.pptx
+++ b/Week08/Week08_Dashboard_Tab.pptx
@@ -3247,7 +3247,7 @@
                   <a:srgbClr val="FFFFFF"/>
                 </a:solidFill>
               </a:rPr>
-              <a:t>Dashboard Tab</a:t>
+              <a:t>ផ្ទាំងគ្រប់គ្រង</a:t>
             </a:r>
           </a:p>
         </p:txBody>
@@ -3281,8 +3281,8 @@
                   <a:srgbClr val="AAAABB"/>
                 </a:solidFill>
               </a:rPr>
-              <a:t>Aggregating data across Finance, Calendar &amp; Journal
-into a single overview screen</a:t>
+              <a:t>ប្រមូលទិន្នន័យពី ហិរញ្ញវត្ថុ ប្រតិទិន &amp; កំណត់ហេតុ
+ចូលក្នុងផ្ទាំងមើលតែមួយ</a:t>
             </a:r>
           </a:p>
         </p:txBody>
@@ -3359,7 +3359,7 @@
                   <a:srgbClr val="FFFFFF"/>
                 </a:solidFill>
               </a:rPr>
-              <a:t>💰  Finance</a:t>
+              <a:t>💰  ហិរញ្ញវត្ថុ</a:t>
             </a:r>
           </a:p>
         </p:txBody>
@@ -3436,7 +3436,7 @@
                   <a:srgbClr val="FFFFFF"/>
                 </a:solidFill>
               </a:rPr>
-              <a:t>📅  Calendar</a:t>
+              <a:t>📅  ប្រតិទិន</a:t>
             </a:r>
           </a:p>
         </p:txBody>
@@ -3513,7 +3513,7 @@
                   <a:srgbClr val="FFFFFF"/>
                 </a:solidFill>
               </a:rPr>
-              <a:t>📖  Journal</a:t>
+              <a:t>📖  កំណត់ហេតុ</a:t>
             </a:r>
           </a:p>
         </p:txBody>
@@ -3590,7 +3590,7 @@
                   <a:srgbClr val="FFFFFF"/>
                 </a:solidFill>
               </a:rPr>
-              <a:t>⚡  Quick Actions</a:t>
+              <a:t>⚡  សកម្មភាពរហ័ស</a:t>
             </a:r>
           </a:p>
         </p:txBody>
@@ -3693,7 +3693,7 @@
                   <a:srgbClr val="FFFFFF"/>
                 </a:solidFill>
               </a:rPr>
-              <a:t>🐛  Common Mistakes</a:t>
+              <a:t>🐛  កំហុសសំខាន់</a:t>
             </a:r>
           </a:p>
         </p:txBody>
@@ -3770,7 +3770,7 @@
                   <a:srgbClr val="E54747"/>
                 </a:solidFill>
               </a:rPr>
-              <a:t>❌ Forget .tag() after reordering</a:t>
+              <a:t>❌ ភ្លេច .tag() ក្រោយ reorder</a:t>
             </a:r>
           </a:p>
         </p:txBody>
@@ -3804,7 +3804,7 @@
                   <a:srgbClr val="AAAABB"/>
                 </a:solidFill>
               </a:rPr>
-              <a:t>→ Notification jumps to wrong tab silently</a:t>
+              <a:t>→ Notification ចូល tab ខុស ដោយស្ងៀម</a:t>
             </a:r>
           </a:p>
         </p:txBody>
@@ -3881,7 +3881,7 @@
                   <a:srgbClr val="1BB889"/>
                 </a:solidFill>
               </a:rPr>
-              <a:t>✅ Always use explicit integer tags on every tab</a:t>
+              <a:t>✅ ប្រើ integer tags ច្បាស់ជានិច្ចរៀងរាល់ tab</a:t>
             </a:r>
           </a:p>
         </p:txBody>
@@ -3958,7 +3958,7 @@
                   <a:srgbClr val="E54747"/>
                 </a:solidFill>
               </a:rPr>
-              <a:t>❌ P&amp;L logic in body computed property</a:t>
+              <a:t>❌ Logic P&amp;L នៅ body computed property</a:t>
             </a:r>
           </a:p>
         </p:txBody>
@@ -3992,7 +3992,7 @@
                   <a:srgbClr val="AAAABB"/>
                 </a:solidFill>
               </a:rPr>
-              <a:t>→ Business logic buried in the view</a:t>
+              <a:t>→ Business logic លាក់ក្នុង View</a:t>
             </a:r>
           </a:p>
         </p:txBody>
@@ -4069,7 +4069,7 @@
                   <a:srgbClr val="1BB889"/>
                 </a:solidFill>
               </a:rPr>
-              <a:t>✅ Move to DashboardViewModel as a pure function</a:t>
+              <a:t>✅ ផ្ទេរទៅ DashboardViewModel ជា pure function</a:t>
             </a:r>
           </a:p>
         </p:txBody>
@@ -4146,7 +4146,7 @@
                   <a:srgbClr val="E54747"/>
                 </a:solidFill>
               </a:rPr>
-              <a:t>❌ Hold FetchedResults&lt;T&gt; in ViewModel</a:t>
+              <a:t>❌ ទុក FetchedResults&lt;T&gt; ក្នុង ViewModel</a:t>
             </a:r>
           </a:p>
         </p:txBody>
@@ -4180,7 +4180,7 @@
                   <a:srgbClr val="AAAABB"/>
                 </a:solidFill>
               </a:rPr>
-              <a:t>→ @FetchRequest only works inside a View</a:t>
+              <a:t>→ @FetchRequest ដំណើរការតែក្នុង View</a:t>
             </a:r>
           </a:p>
         </p:txBody>
@@ -4257,7 +4257,7 @@
                   <a:srgbClr val="1BB889"/>
                 </a:solidFill>
               </a:rPr>
-              <a:t>✅ Pass Array(results) to the ViewModel method</a:t>
+              <a:t>✅ ផ្ញើ Array(results) ទៅ method ViewModel</a:t>
             </a:r>
           </a:p>
         </p:txBody>
@@ -4334,7 +4334,7 @@
                   <a:srgbClr val="E54747"/>
                 </a:solidFill>
               </a:rPr>
-              <a:t>❌ Miss @ViewBuilder on DashboardSection</a:t>
+              <a:t>❌ ខ្វះ @ViewBuilder លើ DashboardSection</a:t>
             </a:r>
           </a:p>
         </p:txBody>
@@ -4445,7 +4445,7 @@
                   <a:srgbClr val="1BB889"/>
                 </a:solidFill>
               </a:rPr>
-              <a:t>✅ Add @ViewBuilder to the closure parameter</a:t>
+              <a:t>✅ បន្ថែម @ViewBuilder ទៅ closure parameter</a:t>
             </a:r>
           </a:p>
         </p:txBody>
@@ -4522,7 +4522,7 @@
                   <a:srgbClr val="E54747"/>
                 </a:solidFill>
               </a:rPr>
-              <a:t>❌ Omit .buttonStyle(PlainButtonStyle())</a:t>
+              <a:t>❌ ភ្លេច .buttonStyle(PlainButtonStyle())</a:t>
             </a:r>
           </a:p>
         </p:txBody>
@@ -4556,7 +4556,7 @@
                   <a:srgbClr val="AAAABB"/>
                 </a:solidFill>
               </a:rPr>
-              <a:t>→ Entire button row turns blue on press</a:t>
+              <a:t>→ row button ទាំងមូលប្រែពណ៌ខៀវពេលចុច</a:t>
             </a:r>
           </a:p>
         </p:txBody>
@@ -4633,7 +4633,7 @@
                   <a:srgbClr val="1BB889"/>
                 </a:solidFill>
               </a:rPr>
-              <a:t>✅ Add .buttonStyle(PlainButtonStyle()) to QuickActionButton</a:t>
+              <a:t>✅ បន្ថែម .buttonStyle(PlainButtonStyle()) ទៅ QuickActionButton</a:t>
             </a:r>
           </a:p>
         </p:txBody>
@@ -4736,7 +4736,7 @@
                   <a:srgbClr val="FFFFFF"/>
                 </a:solidFill>
               </a:rPr>
-              <a:t>🎨  UI / UX Summary</a:t>
+              <a:t>🎨  សង្ខេប UI / UX</a:t>
             </a:r>
           </a:p>
         </p:txBody>
@@ -4856,7 +4856,7 @@
                   <a:srgbClr val="1BB889"/>
                 </a:solidFill>
               </a:rPr>
-              <a:t>Tab icon</a:t>
+              <a:t>រូបតំណាង Tab</a:t>
             </a:r>
           </a:p>
         </p:txBody>
@@ -5010,7 +5010,7 @@
                   <a:srgbClr val="1BB889"/>
                 </a:solidFill>
               </a:rPr>
-              <a:t>P&amp;L positive</a:t>
+              <a:t>P&amp;L វិជ្ជមាន</a:t>
             </a:r>
           </a:p>
         </p:txBody>
@@ -5044,7 +5044,7 @@
                   <a:srgbClr val="AAAABB"/>
                 </a:solidFill>
               </a:rPr>
-              <a:t>Green gradient + up arrow</a:t>
+              <a:t>Green gradient + ព្រួញឡើង</a:t>
             </a:r>
           </a:p>
         </p:txBody>
@@ -5164,7 +5164,7 @@
                   <a:srgbClr val="E54747"/>
                 </a:solidFill>
               </a:rPr>
-              <a:t>P&amp;L negative</a:t>
+              <a:t>P&amp;L អវិជ្ជមាន</a:t>
             </a:r>
           </a:p>
         </p:txBody>
@@ -5198,7 +5198,7 @@
                   <a:srgbClr val="AAAABB"/>
                 </a:solidFill>
               </a:rPr>
-              <a:t>Red gradient + down arrow</a:t>
+              <a:t>Red gradient + ព្រួញចុះ</a:t>
             </a:r>
           </a:p>
         </p:txBody>
@@ -5318,7 +5318,7 @@
                   <a:srgbClr val="1BB889"/>
                 </a:solidFill>
               </a:rPr>
-              <a:t>Finance section</a:t>
+              <a:t>ផ្នែកហិរញ្ញវត្ថុ</a:t>
             </a:r>
           </a:p>
         </p:txBody>
@@ -5472,7 +5472,7 @@
                   <a:srgbClr val="287DFA"/>
                 </a:solidFill>
               </a:rPr>
-              <a:t>Calendar section</a:t>
+              <a:t>ផ្នែកប្រតិទិន</a:t>
             </a:r>
           </a:p>
         </p:txBody>
@@ -5626,7 +5626,7 @@
                   <a:srgbClr val="8E44AD"/>
                 </a:solidFill>
               </a:rPr>
-              <a:t>Journal section</a:t>
+              <a:t>ផ្នែកកំណត់ហេតុ</a:t>
             </a:r>
           </a:p>
         </p:txBody>
@@ -5780,7 +5780,7 @@
                   <a:srgbClr val="F39620"/>
                 </a:solidFill>
               </a:rPr>
-              <a:t>Quick Actions header</a:t>
+              <a:t>header សកម្មភាពរហ័ស</a:t>
             </a:r>
           </a:p>
         </p:txBody>
@@ -5960,7 +5960,7 @@
                   <a:srgbClr val="FFFFFF"/>
                 </a:solidFill>
               </a:rPr>
-              <a:t>✅  Week 8 Summary</a:t>
+              <a:t>✅  សង្ខេប Week 8</a:t>
             </a:r>
           </a:p>
         </p:txBody>
@@ -5994,7 +5994,7 @@
                   <a:srgbClr val="1BB889"/>
                 </a:solidFill>
               </a:rPr>
-              <a:t>What we built:</a:t>
+              <a:t>អ្វីដែលយើងបានបង្កើត:</a:t>
             </a:r>
           </a:p>
         </p:txBody>
@@ -6032,7 +6032,7 @@
                   <a:srgbClr val="FFFFFF"/>
                 </a:solidFill>
               </a:rPr>
-              <a:t>• Built DashboardViewModel with pure functions for monthly P&amp;L, recent items &amp; upcoming tasks</a:t>
+              <a:t>• បានបង្កើត DashboardViewModel ជាមួយ pure functions សម្រាប់ P&amp;L ប្រចាំខែ, items ថ្មីៗ &amp; ភារកិច្ចខាងមុខ</a:t>
             </a:r>
           </a:p>
           <a:p>
@@ -6047,7 +6047,7 @@
                   <a:srgbClr val="FFFFFF"/>
                 </a:solidFill>
               </a:rPr>
-              <a:t>• Created a conditional-colour LinearGradient hero card</a:t>
+              <a:t>• បានបង្កើត hero card LinearGradient conditional-color</a:t>
             </a:r>
           </a:p>
           <a:p>
@@ -6062,7 +6062,7 @@
                   <a:srgbClr val="FFFFFF"/>
                 </a:solidFill>
               </a:rPr>
-              <a:t>• Factored DashboardSection&lt;Content: View&gt; to eliminate repeated card frames</a:t>
+              <a:t>• បានបង្កើត DashboardSection&lt;Content: View&gt; ដើម្បីកម្ចាត់ card frames ដែលដូចគ្នា</a:t>
             </a:r>
           </a:p>
           <a:p>
@@ -6077,7 +6077,7 @@
                   <a:srgbClr val="FFFFFF"/>
                 </a:solidFill>
               </a:rPr>
-              <a:t>• Wrote three row views — one per data source — keeping detail level appropriate for a dashboard</a:t>
+              <a:t>• បានសរសេរ row views ០៣ — មួយសម្រាប់ data source នីមួយៗ</a:t>
             </a:r>
           </a:p>
           <a:p>
@@ -6092,7 +6092,7 @@
                   <a:srgbClr val="FFFFFF"/>
                 </a:solidFill>
               </a:rPr>
-              <a:t>• Wired Quick Action buttons to AddTransactionView, AddActivityView, AddJournalEntryView</a:t>
+              <a:t>• ភ្ជាប់ Quick Action buttons ទៅ AddTransactionView, AddActivityView, AddJournalEntryView</a:t>
             </a:r>
           </a:p>
           <a:p>
@@ -6107,7 +6107,7 @@
                   <a:srgbClr val="FFFFFF"/>
                 </a:solidFill>
               </a:rPr>
-              <a:t>• Updated MainTabView: inserted Dashboard as tab 0, updated notification deep link to tab 2</a:t>
+              <a:t>• ធ្វើបច្ចុប្បន្នភាព MainTabView: បន្ថែម Dashboard ជា tab 0, ធ្វើបច្ចុប្បន្នភាព notification deep link ទៅ tab 2</a:t>
             </a:r>
           </a:p>
         </p:txBody>
@@ -6184,7 +6184,7 @@
                   <a:srgbClr val="F39620"/>
                 </a:solidFill>
               </a:rPr>
-              <a:t>Extension ideas:</a:t>
+              <a:t>គំនិតបន្ថែម:</a:t>
             </a:r>
           </a:p>
         </p:txBody>
@@ -6222,7 +6222,7 @@
                   <a:srgbClr val="AAAABB"/>
                 </a:solidFill>
               </a:rPr>
-              <a:t>• Tap a Recent Transaction row → navigate directly to TransactionDetailView</a:t>
+              <a:t>• ចុច row ប្រតិបត្តិការថ្មីៗ → រុករកដោយផ្ទាល់ទៅ TransactionDetailView</a:t>
             </a:r>
           </a:p>
           <a:p>
@@ -6237,7 +6237,7 @@
                   <a:srgbClr val="AAAABB"/>
                 </a:solidFill>
               </a:rPr>
-              <a:t>• Add a simple bar chart for last 6 months P&amp;L using SwiftUI Path/Shape</a:t>
+              <a:t>• បន្ថែម bar chart សាមញ្ញ P&amp;L ៦ ខែចុងក្រោយ ដោយ SwiftUI Path/Shape</a:t>
             </a:r>
           </a:p>
           <a:p>
@@ -6252,7 +6252,7 @@
                   <a:srgbClr val="AAAABB"/>
                 </a:solidFill>
               </a:rPr>
-              <a:t>• Show a 'streak' counter for consecutive days with journal entries</a:t>
+              <a:t>• បង្ហាញ 'streak' counter ចំពោះថ្ងៃជំនាប់ដែលមានកំណត់ហេតុ</a:t>
             </a:r>
           </a:p>
         </p:txBody>
@@ -6355,7 +6355,7 @@
                   <a:srgbClr val="1BB889"/>
                 </a:solidFill>
               </a:rPr>
-              <a:t>🎯  Learning Objectives</a:t>
+              <a:t>🎯  គោលបំណងរៀន</a:t>
             </a:r>
           </a:p>
         </p:txBody>
@@ -6393,7 +6393,7 @@
                   <a:srgbClr val="FFFFFF"/>
                 </a:solidFill>
               </a:rPr>
-              <a:t>• Fetch data from multiple Core Data entities in one view</a:t>
+              <a:t>• ទាញទិន្នន័យពី CoreData entities ច្រើននៅក្នុង View តែមួយ</a:t>
             </a:r>
           </a:p>
           <a:p>
@@ -6408,7 +6408,7 @@
                   <a:srgbClr val="FFFFFF"/>
                 </a:solidFill>
               </a:rPr>
-              <a:t>• Compute monthly profit/loss using pure ViewModel functions</a:t>
+              <a:t>• គណនាចំណេញ/ខាតប្រចាំខែដោយ ViewModel functions ស្អាត</a:t>
             </a:r>
           </a:p>
           <a:p>
@@ -6423,7 +6423,7 @@
                   <a:srgbClr val="FFFFFF"/>
                 </a:solidFill>
               </a:rPr>
-              <a:t>• Build a gradient summary card with conditional colour</a:t>
+              <a:t>• សាងសង់ gradient card ជាមួយ conditional color</a:t>
             </a:r>
           </a:p>
           <a:p>
@@ -6438,7 +6438,7 @@
                   <a:srgbClr val="FFFFFF"/>
                 </a:solidFill>
               </a:rPr>
-              <a:t>• Create a reusable DashboardSection&lt;Content: View&gt; component</a:t>
+              <a:t>• បង្កើត component DashboardSection&lt;Content: View&gt; ប្រើបានម្ដងហើយម្ដងទៀត</a:t>
             </a:r>
           </a:p>
           <a:p>
@@ -6453,7 +6453,7 @@
                   <a:srgbClr val="FFFFFF"/>
                 </a:solidFill>
               </a:rPr>
-              <a:t>• Wire Quick Action buttons to open Add sheets from the Dashboard</a:t>
+              <a:t>• ភ្ជាប់ Quick Action buttons ទៅ Add sheets ពី Dashboard</a:t>
             </a:r>
           </a:p>
           <a:p>
@@ -6468,7 +6468,7 @@
                   <a:srgbClr val="FFFFFF"/>
                 </a:solidFill>
               </a:rPr>
-              <a:t>• Add a new tab to MainTabView without breaking existing deep links</a:t>
+              <a:t>• បន្ថែម Tab ថ្មីទៅ MainTabView ដោយមិនខូច deep links ដែលមានស្រាប់</a:t>
             </a:r>
           </a:p>
         </p:txBody>
@@ -6571,7 +6571,7 @@
                   <a:srgbClr val="FFFFFF"/>
                 </a:solidFill>
               </a:rPr>
-              <a:t>📊  Dashboard — What It Shows</a:t>
+              <a:t>📊  ផ្ទាំងគ្រប់គ្រង — ចំណុចបង្ហាញ</a:t>
             </a:r>
           </a:p>
         </p:txBody>
@@ -6648,7 +6648,7 @@
                   <a:srgbClr val="1BB889"/>
                 </a:solidFill>
               </a:rPr>
-              <a:t>Monthly P&amp;L Card</a:t>
+              <a:t>កាតចំណេញ/ខាតប្រចាំខែ</a:t>
             </a:r>
           </a:p>
         </p:txBody>
@@ -6682,7 +6682,7 @@
                   <a:srgbClr val="AAAABB"/>
                 </a:solidFill>
               </a:rPr>
-              <a:t>Net profit/loss · Income · Expense · Gradient colour (green = profit)</a:t>
+              <a:t>ចំណេញ/ខាតសុទ្ធ · ចំណូល · ចំណាយ · Gradient color (បៃតង = ចំណេញ)</a:t>
             </a:r>
           </a:p>
         </p:txBody>
@@ -6759,7 +6759,7 @@
                   <a:srgbClr val="1BB889"/>
                 </a:solidFill>
               </a:rPr>
-              <a:t>Recent Transactions</a:t>
+              <a:t>ប្រតិបត្តិការថ្មីៗ</a:t>
             </a:r>
           </a:p>
         </p:txBody>
@@ -6793,7 +6793,7 @@
                   <a:srgbClr val="AAAABB"/>
                 </a:solidFill>
               </a:rPr>
-              <a:t>Last 3 transactions — type icon, note/category, date, amount</a:t>
+              <a:t>ប្រតិបត្តិការ ៣ ចុងក្រោយ — icon ប្រភេទ, note/category, កាលបរិច្ឆេទ, ចំនួន</a:t>
             </a:r>
           </a:p>
         </p:txBody>
@@ -6870,7 +6870,7 @@
                   <a:srgbClr val="287DFA"/>
                 </a:solidFill>
               </a:rPr>
-              <a:t>Upcoming Activities</a:t>
+              <a:t>សកម្មភាពខាងមុខ</a:t>
             </a:r>
           </a:p>
         </p:txBody>
@@ -6904,7 +6904,7 @@
                   <a:srgbClr val="AAAABB"/>
                 </a:solidFill>
               </a:rPr>
-              <a:t>Next 3 pending tasks — type icon, title, date, reminder bell</a:t>
+              <a:t>ភារកិច្ចរង់ចាំ ៣ ខាងមុខ — icon ប្រភេទ, title, កាលបរិច្ឆេទ, កណ្ដឹងរំលឹក</a:t>
             </a:r>
           </a:p>
         </p:txBody>
@@ -6981,7 +6981,7 @@
                   <a:srgbClr val="8E44AD"/>
                 </a:solidFill>
               </a:rPr>
-              <a:t>Latest Journal Entry</a:t>
+              <a:t>កំណត់ហេតុថ្មីបំផុត</a:t>
             </a:r>
           </a:p>
         </p:txBody>
@@ -7015,7 +7015,7 @@
                   <a:srgbClr val="AAAABB"/>
                 </a:solidFill>
               </a:rPr>
-              <a:t>Most recent entry — weather icon, title, snippet, photo count</a:t>
+              <a:t>entry ចុងក្រោយ — icon អាកាសធាតុ, title, snippet, ចំនួនរូបថត</a:t>
             </a:r>
           </a:p>
         </p:txBody>
@@ -7092,7 +7092,7 @@
                   <a:srgbClr val="F39620"/>
                 </a:solidFill>
               </a:rPr>
-              <a:t>Quick Actions</a:t>
+              <a:t>សកម្មភាពរហ័ស</a:t>
             </a:r>
           </a:p>
         </p:txBody>
@@ -7126,7 +7126,7 @@
                   <a:srgbClr val="AAAABB"/>
                 </a:solidFill>
               </a:rPr>
-              <a:t>3 buttons: Add Transaction · Add Activity · Add Journal Entry</a:t>
+              <a:t>៣ buttons: បន្ថែមប្រតិបត្តិការ · បន្ថែមសកម្មភាព · បន្ថែមកំណត់ហេតុ</a:t>
             </a:r>
           </a:p>
         </p:txBody>
@@ -7229,7 +7229,7 @@
                   <a:srgbClr val="FFFFFF"/>
                 </a:solidFill>
               </a:rPr>
-              <a:t>🏛  Architecture — Cross-Module Data Flow</a:t>
+              <a:t>🏛  ស្ថាបត្យកម្ម — លំហូរទិន្នន័យ</a:t>
             </a:r>
           </a:p>
         </p:txBody>
@@ -7263,7 +7263,7 @@
                   <a:srgbClr val="AAAABB"/>
                 </a:solidFill>
               </a:rPr>
-              <a:t>Core Data Stores</a:t>
+              <a:t>ទំនាក់ទំនង CoreData</a:t>
             </a:r>
           </a:p>
         </p:txBody>
@@ -8262,7 +8262,7 @@
                   <a:srgbClr val="F39620"/>
                 </a:solidFill>
               </a:rPr>
-              <a:t>Dashboard is read-only — it never writes to Core Data directly.</a:t>
+              <a:t>Dashboard អានបានតែប៉ុណ្ណោះ — មិនសរសេរ CoreData ផ្ទាល់ឡើយ</a:t>
             </a:r>
           </a:p>
         </p:txBody>
@@ -8365,7 +8365,7 @@
                   <a:srgbClr val="FFFFFF"/>
                 </a:solidFill>
               </a:rPr>
-              <a:t>⚙️  DashboardViewModel — Pure Functions</a:t>
+              <a:t>⚙️  DashboardViewModel — អនុគមន៍ស្អាត</a:t>
             </a:r>
           </a:p>
         </p:txBody>
@@ -8652,7 +8652,7 @@
                   <a:srgbClr val="1BB889"/>
                 </a:solidFill>
               </a:rPr>
-              <a:t>Key Design Rules</a:t>
+              <a:t>គោលការណ៍ Design</a:t>
             </a:r>
           </a:p>
         </p:txBody>
@@ -8729,8 +8729,8 @@
                   <a:srgbClr val="FFFFFF"/>
                 </a:solidFill>
               </a:rPr>
-              <a:t>Receives plain [Entity] arrays
-→ no Core Data context in VM</a:t>
+              <a:t>ទទួល arrays [Entity] ធម្មតា
+→ គ្មាន Core Data context ក្នុង VM</a:t>
             </a:r>
           </a:p>
         </p:txBody>
@@ -8807,8 +8807,8 @@
                   <a:srgbClr val="FFFFFF"/>
                 </a:solidFill>
               </a:rPr>
-              <a:t>@FetchRequest belongs in the
-View, not the ViewModel</a:t>
+              <a:t>@FetchRequest ត្រូវនៅក្នុង View
+មិនមែននៅ ViewModel</a:t>
             </a:r>
           </a:p>
         </p:txBody>
@@ -8885,8 +8885,8 @@
                   <a:srgbClr val="FFFFFF"/>
                 </a:solidFill>
               </a:rPr>
-              <a:t>Pure functions = easy to
-unit test without Core Data</a:t>
+              <a:t>Pure functions = ងាយធ្វើ
+unit test ដោយគ្មាន Core Data</a:t>
             </a:r>
           </a:p>
         </p:txBody>
@@ -8963,8 +8963,8 @@
                   <a:srgbClr val="FFFFFF"/>
                 </a:solidFill>
               </a:rPr>
-              <a:t>currentMonthTransactions() is
-private — only VM uses it</a:t>
+              <a:t>currentMonthTransactions() ជា
+private — VM ប្រើតែម្នាក់ឯង</a:t>
             </a:r>
           </a:p>
         </p:txBody>
@@ -9041,8 +9041,8 @@
                   <a:srgbClr val="FFFFFF"/>
                 </a:solidFill>
               </a:rPr>
-              <a:t>limit: Int = 3 default
-→ callers can override</a:t>
+              <a:t>limit: Int = 3 ជា default
+→ caller អាចផ្លាស់ប្ដូរបាន</a:t>
             </a:r>
           </a:p>
         </p:txBody>
@@ -9145,7 +9145,7 @@
                   <a:srgbClr val="FFFFFF"/>
                 </a:solidFill>
               </a:rPr>
-              <a:t>💳  Monthly Profit / Loss Card</a:t>
+              <a:t>💳  កាតចំណេញ / ខាតប្រចាំខែ</a:t>
             </a:r>
           </a:p>
         </p:txBody>
@@ -9673,7 +9673,7 @@
                   <a:srgbClr val="AAAABB"/>
                 </a:solidFill>
               </a:rPr>
-              <a:t>isProfit flag drives both the gradient colour AND the arrow SF Symbol — computed once, used twice.</a:t>
+              <a:t>isProfit flag ដំណើរការ gradient color AND SF Symbol ព្រមគ្នា — គណនាម្ដង ប្រើពីរ</a:t>
             </a:r>
           </a:p>
         </p:txBody>
@@ -9930,7 +9930,7 @@
                   <a:srgbClr val="FFFFFF"/>
                 </a:solidFill>
               </a:rPr>
-              <a:t>🧩  Reusable DashboardSection&lt;Content: View&gt;</a:t>
+              <a:t>🧩  DashboardSection&lt;Content: View&gt; ប្រើបានម្ដងហើយម្ដងទៀត</a:t>
             </a:r>
           </a:p>
         </p:txBody>
@@ -10261,7 +10261,7 @@
                   <a:srgbClr val="F39620"/>
                 </a:solidFill>
               </a:rPr>
-              <a:t>Why @ViewBuilder?</a:t>
+              <a:t>ហេតុអ្វី @ViewBuilder?</a:t>
             </a:r>
           </a:p>
         </p:txBody>
@@ -10295,11 +10295,11 @@
                   <a:srgbClr val="FFFFFF"/>
                 </a:solidFill>
               </a:rPr>
-              <a:t>Without @ViewBuilder, the closure
-can only have ONE expression.
-With @ViewBuilder, callers can write
-if, ForEach, multiple rows —
-full SwiftUI DSL syntax.</a:t>
+              <a:t>ដោយគ្មាន @ViewBuilder closure
+អាចមាន expression តែMỘT។
+ជាមួយ @ViewBuilder caller
+អាចសរសេរ if, ForEach, rows ច្រើន —
+complete SwiftUI DSL syntax</a:t>
             </a:r>
           </a:p>
         </p:txBody>
@@ -10333,7 +10333,7 @@
                   <a:srgbClr val="1BB889"/>
                 </a:solidFill>
               </a:rPr>
-              <a:t>Usage:</a:t>
+              <a:t>ការប្រើប្រាស់:</a:t>
             </a:r>
           </a:p>
         </p:txBody>
@@ -10601,7 +10601,7 @@
                   <a:srgbClr val="FFFFFF"/>
                 </a:solidFill>
               </a:rPr>
-              <a:t>⚡  Quick Actions</a:t>
+              <a:t>⚡  សកម្មភាពរហ័ស</a:t>
             </a:r>
           </a:p>
         </p:txBody>
@@ -10995,7 +10995,7 @@
                   <a:srgbClr val="AAAABB"/>
                 </a:solidFill>
               </a:rPr>
-              <a:t>Each button sets a @State Bool flag → .sheet(isPresented:) opens the correct Add view.</a:t>
+              <a:t>Button នីមួយៗ កំណត់ @State Bool flag → .sheet(isPresented:) បើក Add view ត្រឹមត្រូវ</a:t>
             </a:r>
           </a:p>
         </p:txBody>
@@ -11285,7 +11285,7 @@
                   <a:srgbClr val="FFFFFF"/>
                 </a:solidFill>
               </a:rPr>
-              <a:t>🔧  Updating MainTabView — Adding Tab 0</a:t>
+              <a:t>🔧  ធ្វើបច្ចុប្បន្នភាព MainTabView — បន្ថែម Tab 0</a:t>
             </a:r>
           </a:p>
         </p:txBody>
@@ -11319,7 +11319,7 @@
                   <a:srgbClr val="E54747"/>
                 </a:solidFill>
               </a:rPr>
-              <a:t>Before (Week 7)</a:t>
+              <a:t>មុន (Week 7)</a:t>
             </a:r>
           </a:p>
         </p:txBody>
@@ -11353,7 +11353,7 @@
                   <a:srgbClr val="1BB889"/>
                 </a:solidFill>
               </a:rPr>
-              <a:t>After (Week 8)</a:t>
+              <a:t>ក្រោយ (Week 8)</a:t>
             </a:r>
           </a:p>
         </p:txBody>
@@ -11727,7 +11727,7 @@
                   <a:srgbClr val="F39620"/>
                 </a:solidFill>
               </a:rPr>
-              <a:t>⚠️  Rule: always use explicit .tag() — implicit indices break silently when tabs are reordered.</a:t>
+              <a:t>⚠️  ច្បាប់: ប្រើ .tag() ច្បាស់លាស់ — indices ប្រូតស្ងៀមមួយ ខូចដោយមិនដឹង</a:t>
             </a:r>
           </a:p>
         </p:txBody>
@@ -11761,7 +11761,7 @@
                   <a:srgbClr val="F39620"/>
                 </a:solidFill>
               </a:rPr>
-              <a:t>⚠️  Update ALL hardcoded tab indices (here: the notification deep link).</a:t>
+              <a:t>⚠️  ធ្វើបច្ចុប្បន្នភាព tab indices hardcoded ទាំងអស់ (notification deep link)</a:t>
             </a:r>
           </a:p>
         </p:txBody>

</xml_diff>